<commit_message>
115 added and 113 final updated
</commit_message>
<xml_diff>
--- a/InfoSec/CIS 115 Week 2.pptx
+++ b/InfoSec/CIS 115 Week 2.pptx
@@ -135,6 +135,172 @@
     <p1510:client id="{A5FF3B86-B791-4B54-80D6-4AC9408E13DA}" v="66" dt="2023-09-19T14:36:20.921"/>
   </p1510:revLst>
 </p1510:revInfo>
+</file>
+
+<file path=ppt/changesInfos/changesInfo1.xml><?xml version="1.0" encoding="utf-8"?>
+<pc:chgInfo xmlns:a="http://schemas.openxmlformats.org/drawingml/2006/main" xmlns:r="http://schemas.openxmlformats.org/officeDocument/2006/relationships" xmlns:ac="http://schemas.microsoft.com/office/drawing/2013/main/command" xmlns:pc="http://schemas.microsoft.com/office/powerpoint/2013/main/command">
+  <pc:docChgLst>
+    <pc:chgData name="Adrianna Holden-Gouveia" userId="8de7044ed950bdf3" providerId="Windows Live" clId="Web-{A5FF3B86-B791-4B54-80D6-4AC9408E13DA}"/>
+    <pc:docChg chg="modSld">
+      <pc:chgData name="Adrianna Holden-Gouveia" userId="8de7044ed950bdf3" providerId="Windows Live" clId="Web-{A5FF3B86-B791-4B54-80D6-4AC9408E13DA}" dt="2023-09-19T14:36:20.921" v="62" actId="14100"/>
+      <pc:docMkLst>
+        <pc:docMk/>
+      </pc:docMkLst>
+      <pc:sldChg chg="modSp">
+        <pc:chgData name="Adrianna Holden-Gouveia" userId="8de7044ed950bdf3" providerId="Windows Live" clId="Web-{A5FF3B86-B791-4B54-80D6-4AC9408E13DA}" dt="2023-09-19T14:33:53.331" v="41" actId="14100"/>
+        <pc:sldMkLst>
+          <pc:docMk/>
+          <pc:sldMk cId="1445320156" sldId="257"/>
+        </pc:sldMkLst>
+        <pc:spChg chg="mod">
+          <ac:chgData name="Adrianna Holden-Gouveia" userId="8de7044ed950bdf3" providerId="Windows Live" clId="Web-{A5FF3B86-B791-4B54-80D6-4AC9408E13DA}" dt="2023-09-19T14:33:49.065" v="40" actId="14100"/>
+          <ac:spMkLst>
+            <pc:docMk/>
+            <pc:sldMk cId="1445320156" sldId="257"/>
+            <ac:spMk id="3" creationId="{00000000-0000-0000-0000-000000000000}"/>
+          </ac:spMkLst>
+        </pc:spChg>
+        <pc:picChg chg="mod">
+          <ac:chgData name="Adrianna Holden-Gouveia" userId="8de7044ed950bdf3" providerId="Windows Live" clId="Web-{A5FF3B86-B791-4B54-80D6-4AC9408E13DA}" dt="2023-09-19T14:33:53.331" v="41" actId="14100"/>
+          <ac:picMkLst>
+            <pc:docMk/>
+            <pc:sldMk cId="1445320156" sldId="257"/>
+            <ac:picMk id="4" creationId="{00000000-0000-0000-0000-000000000000}"/>
+          </ac:picMkLst>
+        </pc:picChg>
+      </pc:sldChg>
+      <pc:sldChg chg="modSp">
+        <pc:chgData name="Adrianna Holden-Gouveia" userId="8de7044ed950bdf3" providerId="Windows Live" clId="Web-{A5FF3B86-B791-4B54-80D6-4AC9408E13DA}" dt="2023-09-19T14:33:40.987" v="39" actId="1076"/>
+        <pc:sldMkLst>
+          <pc:docMk/>
+          <pc:sldMk cId="3611034823" sldId="258"/>
+        </pc:sldMkLst>
+        <pc:spChg chg="mod">
+          <ac:chgData name="Adrianna Holden-Gouveia" userId="8de7044ed950bdf3" providerId="Windows Live" clId="Web-{A5FF3B86-B791-4B54-80D6-4AC9408E13DA}" dt="2023-09-19T14:33:35.002" v="37" actId="14100"/>
+          <ac:spMkLst>
+            <pc:docMk/>
+            <pc:sldMk cId="3611034823" sldId="258"/>
+            <ac:spMk id="3" creationId="{00000000-0000-0000-0000-000000000000}"/>
+          </ac:spMkLst>
+        </pc:spChg>
+        <pc:picChg chg="mod">
+          <ac:chgData name="Adrianna Holden-Gouveia" userId="8de7044ed950bdf3" providerId="Windows Live" clId="Web-{A5FF3B86-B791-4B54-80D6-4AC9408E13DA}" dt="2023-09-19T14:33:40.987" v="39" actId="1076"/>
+          <ac:picMkLst>
+            <pc:docMk/>
+            <pc:sldMk cId="3611034823" sldId="258"/>
+            <ac:picMk id="4" creationId="{00000000-0000-0000-0000-000000000000}"/>
+          </ac:picMkLst>
+        </pc:picChg>
+      </pc:sldChg>
+      <pc:sldChg chg="modSp">
+        <pc:chgData name="Adrianna Holden-Gouveia" userId="8de7044ed950bdf3" providerId="Windows Live" clId="Web-{A5FF3B86-B791-4B54-80D6-4AC9408E13DA}" dt="2023-09-19T14:11:17.370" v="5" actId="20577"/>
+        <pc:sldMkLst>
+          <pc:docMk/>
+          <pc:sldMk cId="253957118" sldId="259"/>
+        </pc:sldMkLst>
+        <pc:spChg chg="mod">
+          <ac:chgData name="Adrianna Holden-Gouveia" userId="8de7044ed950bdf3" providerId="Windows Live" clId="Web-{A5FF3B86-B791-4B54-80D6-4AC9408E13DA}" dt="2023-09-19T14:11:17.370" v="5" actId="20577"/>
+          <ac:spMkLst>
+            <pc:docMk/>
+            <pc:sldMk cId="253957118" sldId="259"/>
+            <ac:spMk id="3" creationId="{00000000-0000-0000-0000-000000000000}"/>
+          </ac:spMkLst>
+        </pc:spChg>
+      </pc:sldChg>
+      <pc:sldChg chg="addSp delSp modSp">
+        <pc:chgData name="Adrianna Holden-Gouveia" userId="8de7044ed950bdf3" providerId="Windows Live" clId="Web-{A5FF3B86-B791-4B54-80D6-4AC9408E13DA}" dt="2023-09-19T14:36:08.795" v="61"/>
+        <pc:sldMkLst>
+          <pc:docMk/>
+          <pc:sldMk cId="1994448559" sldId="263"/>
+        </pc:sldMkLst>
+        <pc:spChg chg="mod">
+          <ac:chgData name="Adrianna Holden-Gouveia" userId="8de7044ed950bdf3" providerId="Windows Live" clId="Web-{A5FF3B86-B791-4B54-80D6-4AC9408E13DA}" dt="2023-09-19T14:34:14.849" v="44" actId="14100"/>
+          <ac:spMkLst>
+            <pc:docMk/>
+            <pc:sldMk cId="1994448559" sldId="263"/>
+            <ac:spMk id="3" creationId="{00000000-0000-0000-0000-000000000000}"/>
+          </ac:spMkLst>
+        </pc:spChg>
+        <pc:picChg chg="del mod">
+          <ac:chgData name="Adrianna Holden-Gouveia" userId="8de7044ed950bdf3" providerId="Windows Live" clId="Web-{A5FF3B86-B791-4B54-80D6-4AC9408E13DA}" dt="2023-09-19T14:35:11.540" v="48"/>
+          <ac:picMkLst>
+            <pc:docMk/>
+            <pc:sldMk cId="1994448559" sldId="263"/>
+            <ac:picMk id="4" creationId="{00000000-0000-0000-0000-000000000000}"/>
+          </ac:picMkLst>
+        </pc:picChg>
+        <pc:picChg chg="add mod">
+          <ac:chgData name="Adrianna Holden-Gouveia" userId="8de7044ed950bdf3" providerId="Windows Live" clId="Web-{A5FF3B86-B791-4B54-80D6-4AC9408E13DA}" dt="2023-09-19T14:36:08.795" v="61"/>
+          <ac:picMkLst>
+            <pc:docMk/>
+            <pc:sldMk cId="1994448559" sldId="263"/>
+            <ac:picMk id="5" creationId="{3CF0CC4B-2DEE-3072-1BDD-03CA5D873C9E}"/>
+          </ac:picMkLst>
+        </pc:picChg>
+      </pc:sldChg>
+      <pc:sldChg chg="modSp">
+        <pc:chgData name="Adrianna Holden-Gouveia" userId="8de7044ed950bdf3" providerId="Windows Live" clId="Web-{A5FF3B86-B791-4B54-80D6-4AC9408E13DA}" dt="2023-09-19T14:36:20.921" v="62" actId="14100"/>
+        <pc:sldMkLst>
+          <pc:docMk/>
+          <pc:sldMk cId="3538513447" sldId="266"/>
+        </pc:sldMkLst>
+        <pc:picChg chg="mod">
+          <ac:chgData name="Adrianna Holden-Gouveia" userId="8de7044ed950bdf3" providerId="Windows Live" clId="Web-{A5FF3B86-B791-4B54-80D6-4AC9408E13DA}" dt="2023-09-19T14:36:20.921" v="62" actId="14100"/>
+          <ac:picMkLst>
+            <pc:docMk/>
+            <pc:sldMk cId="3538513447" sldId="266"/>
+            <ac:picMk id="4" creationId="{00000000-0000-0000-0000-000000000000}"/>
+          </ac:picMkLst>
+        </pc:picChg>
+      </pc:sldChg>
+      <pc:sldChg chg="modSp">
+        <pc:chgData name="Adrianna Holden-Gouveia" userId="8de7044ed950bdf3" providerId="Windows Live" clId="Web-{A5FF3B86-B791-4B54-80D6-4AC9408E13DA}" dt="2023-09-19T14:34:03.863" v="43" actId="1076"/>
+        <pc:sldMkLst>
+          <pc:docMk/>
+          <pc:sldMk cId="2989561234" sldId="267"/>
+        </pc:sldMkLst>
+        <pc:picChg chg="mod">
+          <ac:chgData name="Adrianna Holden-Gouveia" userId="8de7044ed950bdf3" providerId="Windows Live" clId="Web-{A5FF3B86-B791-4B54-80D6-4AC9408E13DA}" dt="2023-09-19T14:34:03.863" v="43" actId="1076"/>
+          <ac:picMkLst>
+            <pc:docMk/>
+            <pc:sldMk cId="2989561234" sldId="267"/>
+            <ac:picMk id="4" creationId="{00000000-0000-0000-0000-000000000000}"/>
+          </ac:picMkLst>
+        </pc:picChg>
+      </pc:sldChg>
+      <pc:sldChg chg="modSp">
+        <pc:chgData name="Adrianna Holden-Gouveia" userId="8de7044ed950bdf3" providerId="Windows Live" clId="Web-{A5FF3B86-B791-4B54-80D6-4AC9408E13DA}" dt="2023-09-19T14:22:03.403" v="36" actId="20577"/>
+        <pc:sldMkLst>
+          <pc:docMk/>
+          <pc:sldMk cId="2406666442" sldId="269"/>
+        </pc:sldMkLst>
+        <pc:spChg chg="mod">
+          <ac:chgData name="Adrianna Holden-Gouveia" userId="8de7044ed950bdf3" providerId="Windows Live" clId="Web-{A5FF3B86-B791-4B54-80D6-4AC9408E13DA}" dt="2023-09-19T14:22:03.403" v="36" actId="20577"/>
+          <ac:spMkLst>
+            <pc:docMk/>
+            <pc:sldMk cId="2406666442" sldId="269"/>
+            <ac:spMk id="3" creationId="{00000000-0000-0000-0000-000000000000}"/>
+          </ac:spMkLst>
+        </pc:spChg>
+      </pc:sldChg>
+      <pc:sldChg chg="modSp">
+        <pc:chgData name="Adrianna Holden-Gouveia" userId="8de7044ed950bdf3" providerId="Windows Live" clId="Web-{A5FF3B86-B791-4B54-80D6-4AC9408E13DA}" dt="2023-09-19T14:04:47.153" v="2" actId="20577"/>
+        <pc:sldMkLst>
+          <pc:docMk/>
+          <pc:sldMk cId="4024773539" sldId="270"/>
+        </pc:sldMkLst>
+        <pc:spChg chg="mod">
+          <ac:chgData name="Adrianna Holden-Gouveia" userId="8de7044ed950bdf3" providerId="Windows Live" clId="Web-{A5FF3B86-B791-4B54-80D6-4AC9408E13DA}" dt="2023-09-19T14:04:47.153" v="2" actId="20577"/>
+          <ac:spMkLst>
+            <pc:docMk/>
+            <pc:sldMk cId="4024773539" sldId="270"/>
+            <ac:spMk id="3" creationId="{00000000-0000-0000-0000-000000000000}"/>
+          </ac:spMkLst>
+        </pc:spChg>
+      </pc:sldChg>
+    </pc:docChg>
+  </pc:docChgLst>
+</pc:chgInfo>
 </file>
 
 <file path=ppt/notesMasters/notesMaster1.xml><?xml version="1.0" encoding="utf-8"?>
@@ -6925,7 +7091,7 @@
           <a:p>
             <a:r>
               <a:rPr lang="en-US"/>
-              <a:t>Ipods (podsnarfing)</a:t>
+              <a:t>iPods (podsnarfing)</a:t>
             </a:r>
           </a:p>
           <a:p>
@@ -6937,7 +7103,7 @@
           <a:p>
             <a:r>
               <a:rPr lang="en-US"/>
-              <a:t>Usb drives (thumbsucking)</a:t>
+              <a:t>USB drives (thumbsucking)</a:t>
             </a:r>
           </a:p>
           <a:p>
@@ -7900,7 +8066,7 @@
             <a:pPr lvl="1"/>
             <a:r>
               <a:rPr lang="en-US" dirty="0"/>
-              <a:t>Occupy Wallstreet</a:t>
+              <a:t>Occupy Wall Street</a:t>
             </a:r>
           </a:p>
           <a:p>

</xml_diff>